<commit_message>
update kế hoạch tháng 9 và bổ sung meeting note kickoff dự án
</commit_message>
<xml_diff>
--- a/03_product/concepts/AI-Class-Plus-concept-1.2-slide-deck-ban-hang-2026-09-04-final.pptx
+++ b/03_product/concepts/AI-Class-Plus-concept-1.2-slide-deck-ban-hang-2026-09-04-final.pptx
@@ -15271,7 +15271,7 @@
                           <a:cs typeface="Arial"/>
                           <a:sym typeface="Arial"/>
                         </a:rPr>
-                        <a:t>Kèm riêng 30 phút cuối buổi</a:t>
+                        <a:t>Kèm riêng 30 phút sau buổi học</a:t>
                       </a:r>
                       <a:endParaRPr sz="1400" u="none" cap="none" strike="noStrike">
                         <a:latin typeface="Arial"/>
@@ -15352,7 +15352,7 @@
                           <a:cs typeface="Arial"/>
                           <a:sym typeface="Arial"/>
                         </a:rPr>
-                        <a:t>Khi con cần</a:t>
+                        <a:t>Sau mỗi buổi</a:t>
                       </a:r>
                       <a:endParaRPr sz="1400" u="none" cap="none" strike="noStrike">
                         <a:latin typeface="Arial"/>
@@ -15433,7 +15433,7 @@
                           <a:cs typeface="Arial"/>
                           <a:sym typeface="Arial"/>
                         </a:rPr>
-                        <a:t>Nếu con chưa theo kịp, được kèm 1-1 với AI ngay lúc đó</a:t>
+                        <a:t>Mặc định ai cũng được kèm 1-1 với AI — giỏi thì nâng cao, yếu thì vá lỗ hổng</a:t>
                       </a:r>
                       <a:endParaRPr sz="1400" u="none" cap="none" strike="noStrike">
                         <a:latin typeface="Arial"/>
@@ -18506,7 +18506,7 @@
                 <a:cs typeface="Arial"/>
                 <a:sym typeface="Arial"/>
               </a:rPr>
-              <a:t>Con chưa hiểu bài? Được kèm ngay trong buổi</a:t>
+              <a:t>Sau mỗi buổi học, con đều được kèm riêng 30 phút</a:t>
             </a:r>
             <a:endParaRPr b="0" i="0" sz="2200" u="none" cap="none" strike="noStrike">
               <a:solidFill>
@@ -18595,7 +18595,7 @@
                 <a:cs typeface="Arial"/>
                 <a:sym typeface="Arial"/>
               </a:rPr>
-              <a:t>Kèm riêng 30 phút cuối buổi: </a:t>
+              <a:t>Kèm riêng 30 phút sau buổi học: </a:t>
             </a:r>
             <a:r>
               <a:rPr b="0" i="0" lang="en-US" sz="1600" u="none" cap="none" strike="noStrike">
@@ -18607,7 +18607,7 @@
                 <a:cs typeface="Arial"/>
                 <a:sym typeface="Arial"/>
               </a:rPr>
-              <a:t>nếu trong buổi học chính con chưa theo kịp, con được chuyển sang học riêng 1-1 với AI trong 30 phút cuối buổi để xử lý phần vừa hổng.</a:t>
+              <a:t>đây là bước mặc định sau mỗi buổi học chính, chia theo năng lực của con — con khá giỏi được nâng cao, mở rộng thêm kiến thức; con trung bình/yếu được vá lỗ hổng, củng cố lại kiến thức vừa học.</a:t>
             </a:r>
             <a:endParaRPr b="0" i="0" sz="1600" u="none" cap="none" strike="noStrike">
               <a:solidFill>
@@ -18702,7 +18702,7 @@
                 <a:cs typeface="Arial"/>
                 <a:sym typeface="Arial"/>
               </a:rPr>
-              <a:t>. Edupia cố gắng xử lý ngay từ bước: </a:t>
+              <a:t>. Ngược lại, con học giỏi cũng dễ chán nếu chỉ học đúng những gì cả lớp học. Edupia xử lý cả hai chiều ngay sau mỗi buổi: </a:t>
             </a:r>
             <a:r>
               <a:rPr b="1" i="0" lang="en-US" sz="1600" u="none" cap="none" strike="noStrike">
@@ -18710,7 +18710,7 @@
                   <a:srgbClr val="1F2A33"/>
                 </a:solidFill>
               </a:rPr>
-              <a:t>Chưa hiểu → kèm ngay → hiểu bài → về nhà luyện tiếp</a:t>
+              <a:t>con chưa hiểu thì được củng cố ngay, con đã vững thì được học thêm</a:t>
             </a:r>
             <a:r>
               <a:rPr b="0" i="0" lang="en-US" sz="1600" u="none" cap="none" strike="noStrike">
@@ -18899,7 +18899,7 @@
                 <a:cs typeface="Arial"/>
                 <a:sym typeface="Arial"/>
               </a:rPr>
-              <a:t>"Nếu trong buổi học con chưa theo kịp, con được kèm riêng ngay 30 phút cuối để xử lý phần chưa hiểu. Như vậy con không phải mang chỗ hổng đó về nhà rồi tự mò một mình."</a:t>
+              <a:t>"Sau mỗi buổi học, con nào cũng được kèm riêng 30 phút với AI — không phải đợi con học kém mới có. Nếu con theo kịp tốt, AI sẽ dạy thêm để mở rộng kiến thức. Nếu con chưa theo kịp, AI sẽ củng cố lại đúng phần con chưa hiểu, để con không phải mang chỗ hổng đó về nhà rồi tự mò một mình."</a:t>
             </a:r>
             <a:endParaRPr b="0" i="0" sz="1600" u="none" cap="none" strike="noStrike">
               <a:solidFill>

</xml_diff>